<commit_message>
Tighten paper report layout auditing
</commit_message>
<xml_diff>
--- a/skills/uav-paper-report/assets/examples/ego-planner-report.pptx
+++ b/skills/uav-paper-report/assets/examples/ego-planner-report.pptx
@@ -3098,7 +3098,7 @@
 </file>
 
 <file path=ppt/slides/slide1.xml><?xml version="1.0" encoding="utf-8"?>
-<p:sld xmlns:a="http://schemas.openxmlformats.org/drawingml/2006/main" xmlns:p="http://schemas.openxmlformats.org/presentationml/2006/main" xmlns:r="http://schemas.openxmlformats.org/officeDocument/2006/relationships">
+<p:sld xmlns:a="http://schemas.openxmlformats.org/drawingml/2006/main" xmlns:ns2="http://schemas.openxmlformats.org/officeDocument/2006/relationships" xmlns:p="http://schemas.openxmlformats.org/presentationml/2006/main">
   <p:cSld>
     <p:spTree>
       <p:nvGrpSpPr>
@@ -3116,7 +3116,7 @@
           <p:nvPr/>
         </p:nvPicPr>
         <p:blipFill>
-          <a:blip r:embed="rId2"/>
+          <a:blip ns2:embed="rId2"/>
           <a:stretch>
             <a:fillRect/>
           </a:stretch>
@@ -3166,13 +3166,6 @@
             <a:schemeClr val="lt1"/>
           </a:fontRef>
         </p:style>
-        <p:txBody>
-          <a:bodyPr rtlCol="0" anchor="ctr"/>
-          <a:lstStyle/>
-          <a:p>
-            <a:pPr algn="ctr"/>
-          </a:p>
-        </p:txBody>
       </p:sp>
       <p:sp>
         <p:nvSpPr>
@@ -3372,7 +3365,7 @@
 </file>
 
 <file path=ppt/slides/slide10.xml><?xml version="1.0" encoding="utf-8"?>
-<p:sld xmlns:a="http://schemas.openxmlformats.org/drawingml/2006/main" xmlns:p="http://schemas.openxmlformats.org/presentationml/2006/main" xmlns:r="http://schemas.openxmlformats.org/officeDocument/2006/relationships">
+<p:sld xmlns:a="http://schemas.openxmlformats.org/drawingml/2006/main" xmlns:ns2="http://schemas.openxmlformats.org/officeDocument/2006/relationships" xmlns:p="http://schemas.openxmlformats.org/presentationml/2006/main">
   <p:cSld>
     <p:spTree>
       <p:nvGrpSpPr>
@@ -3416,13 +3409,6 @@
             <a:schemeClr val="lt1"/>
           </a:fontRef>
         </p:style>
-        <p:txBody>
-          <a:bodyPr rtlCol="0" anchor="ctr"/>
-          <a:lstStyle/>
-          <a:p>
-            <a:pPr algn="ctr"/>
-          </a:p>
-        </p:txBody>
       </p:sp>
       <p:pic>
         <p:nvPicPr>
@@ -3433,7 +3419,7 @@
           <p:nvPr/>
         </p:nvPicPr>
         <p:blipFill>
-          <a:blip r:embed="rId2"/>
+          <a:blip ns2:embed="rId2"/>
           <a:stretch>
             <a:fillRect/>
           </a:stretch>
@@ -4163,13 +4149,6 @@
             <a:schemeClr val="lt1"/>
           </a:fontRef>
         </p:style>
-        <p:txBody>
-          <a:bodyPr rtlCol="0" anchor="ctr"/>
-          <a:lstStyle/>
-          <a:p>
-            <a:pPr algn="ctr"/>
-          </a:p>
-        </p:txBody>
       </p:sp>
       <p:sp>
         <p:nvSpPr>
@@ -4363,7 +4342,7 @@
 </file>
 
 <file path=ppt/slides/slide11.xml><?xml version="1.0" encoding="utf-8"?>
-<p:sld xmlns:a="http://schemas.openxmlformats.org/drawingml/2006/main" xmlns:p="http://schemas.openxmlformats.org/presentationml/2006/main" xmlns:r="http://schemas.openxmlformats.org/officeDocument/2006/relationships">
+<p:sld xmlns:a="http://schemas.openxmlformats.org/drawingml/2006/main" xmlns:ns2="http://schemas.openxmlformats.org/officeDocument/2006/relationships" xmlns:p="http://schemas.openxmlformats.org/presentationml/2006/main">
   <p:cSld>
     <p:spTree>
       <p:nvGrpSpPr>
@@ -4407,13 +4386,6 @@
             <a:schemeClr val="lt1"/>
           </a:fontRef>
         </p:style>
-        <p:txBody>
-          <a:bodyPr rtlCol="0" anchor="ctr"/>
-          <a:lstStyle/>
-          <a:p>
-            <a:pPr algn="ctr"/>
-          </a:p>
-        </p:txBody>
       </p:sp>
       <p:pic>
         <p:nvPicPr>
@@ -4424,7 +4396,7 @@
           <p:nvPr/>
         </p:nvPicPr>
         <p:blipFill>
-          <a:blip r:embed="rId2"/>
+          <a:blip ns2:embed="rId2"/>
           <a:stretch>
             <a:fillRect/>
           </a:stretch>
@@ -4593,7 +4565,7 @@
           <p:nvPr/>
         </p:nvPicPr>
         <p:blipFill>
-          <a:blip r:embed="rId3"/>
+          <a:blip ns2:embed="rId3"/>
           <a:stretch>
             <a:fillRect/>
           </a:stretch>
@@ -4922,13 +4894,6 @@
             <a:schemeClr val="lt1"/>
           </a:fontRef>
         </p:style>
-        <p:txBody>
-          <a:bodyPr rtlCol="0" anchor="ctr"/>
-          <a:lstStyle/>
-          <a:p>
-            <a:pPr algn="ctr"/>
-          </a:p>
-        </p:txBody>
       </p:sp>
       <p:sp>
         <p:nvSpPr>
@@ -4986,7 +4951,7 @@
 </file>
 
 <file path=ppt/slides/slide12.xml><?xml version="1.0" encoding="utf-8"?>
-<p:sld xmlns:a="http://schemas.openxmlformats.org/drawingml/2006/main" xmlns:p="http://schemas.openxmlformats.org/presentationml/2006/main" xmlns:r="http://schemas.openxmlformats.org/officeDocument/2006/relationships">
+<p:sld xmlns:a="http://schemas.openxmlformats.org/drawingml/2006/main" xmlns:ns2="http://schemas.openxmlformats.org/officeDocument/2006/relationships" xmlns:p="http://schemas.openxmlformats.org/presentationml/2006/main">
   <p:cSld>
     <p:spTree>
       <p:nvGrpSpPr>
@@ -5030,13 +4995,6 @@
             <a:schemeClr val="lt1"/>
           </a:fontRef>
         </p:style>
-        <p:txBody>
-          <a:bodyPr rtlCol="0" anchor="ctr"/>
-          <a:lstStyle/>
-          <a:p>
-            <a:pPr algn="ctr"/>
-          </a:p>
-        </p:txBody>
       </p:sp>
       <p:pic>
         <p:nvPicPr>
@@ -5047,7 +5005,7 @@
           <p:nvPr/>
         </p:nvPicPr>
         <p:blipFill>
-          <a:blip r:embed="rId2"/>
+          <a:blip ns2:embed="rId2"/>
           <a:stretch>
             <a:fillRect/>
           </a:stretch>
@@ -5238,7 +5196,7 @@
           <p:nvPr/>
         </p:nvPicPr>
         <p:blipFill>
-          <a:blip r:embed="rId3"/>
+          <a:blip ns2:embed="rId3"/>
           <a:stretch>
             <a:fillRect/>
           </a:stretch>
@@ -5288,13 +5246,6 @@
             <a:schemeClr val="lt1"/>
           </a:fontRef>
         </p:style>
-        <p:txBody>
-          <a:bodyPr rtlCol="0" anchor="ctr"/>
-          <a:lstStyle/>
-          <a:p>
-            <a:pPr algn="ctr"/>
-          </a:p>
-        </p:txBody>
       </p:sp>
       <p:sp>
         <p:nvSpPr>
@@ -5398,7 +5349,7 @@
 </file>
 
 <file path=ppt/slides/slide13.xml><?xml version="1.0" encoding="utf-8"?>
-<p:sld xmlns:a="http://schemas.openxmlformats.org/drawingml/2006/main" xmlns:p="http://schemas.openxmlformats.org/presentationml/2006/main" xmlns:r="http://schemas.openxmlformats.org/officeDocument/2006/relationships">
+<p:sld xmlns:a="http://schemas.openxmlformats.org/drawingml/2006/main" xmlns:ns2="http://schemas.openxmlformats.org/officeDocument/2006/relationships" xmlns:p="http://schemas.openxmlformats.org/presentationml/2006/main">
   <p:cSld>
     <p:spTree>
       <p:nvGrpSpPr>
@@ -5442,13 +5393,6 @@
             <a:schemeClr val="lt1"/>
           </a:fontRef>
         </p:style>
-        <p:txBody>
-          <a:bodyPr rtlCol="0" anchor="ctr"/>
-          <a:lstStyle/>
-          <a:p>
-            <a:pPr algn="ctr"/>
-          </a:p>
-        </p:txBody>
       </p:sp>
       <p:pic>
         <p:nvPicPr>
@@ -5459,7 +5403,7 @@
           <p:nvPr/>
         </p:nvPicPr>
         <p:blipFill>
-          <a:blip r:embed="rId2"/>
+          <a:blip ns2:embed="rId2"/>
           <a:stretch>
             <a:fillRect/>
           </a:stretch>
@@ -6812,7 +6756,7 @@
 </file>
 
 <file path=ppt/slides/slide14.xml><?xml version="1.0" encoding="utf-8"?>
-<p:sld xmlns:a="http://schemas.openxmlformats.org/drawingml/2006/main" xmlns:p="http://schemas.openxmlformats.org/presentationml/2006/main" xmlns:r="http://schemas.openxmlformats.org/officeDocument/2006/relationships">
+<p:sld xmlns:a="http://schemas.openxmlformats.org/drawingml/2006/main" xmlns:ns2="http://schemas.openxmlformats.org/officeDocument/2006/relationships" xmlns:p="http://schemas.openxmlformats.org/presentationml/2006/main">
   <p:cSld>
     <p:spTree>
       <p:nvGrpSpPr>
@@ -6856,13 +6800,6 @@
             <a:schemeClr val="lt1"/>
           </a:fontRef>
         </p:style>
-        <p:txBody>
-          <a:bodyPr rtlCol="0" anchor="ctr"/>
-          <a:lstStyle/>
-          <a:p>
-            <a:pPr algn="ctr"/>
-          </a:p>
-        </p:txBody>
       </p:sp>
       <p:pic>
         <p:nvPicPr>
@@ -6873,7 +6810,7 @@
           <p:nvPr/>
         </p:nvPicPr>
         <p:blipFill>
-          <a:blip r:embed="rId2"/>
+          <a:blip ns2:embed="rId2"/>
           <a:stretch>
             <a:fillRect/>
           </a:stretch>
@@ -7064,7 +7001,7 @@
           <p:nvPr/>
         </p:nvPicPr>
         <p:blipFill>
-          <a:blip r:embed="rId3"/>
+          <a:blip ns2:embed="rId3"/>
           <a:stretch>
             <a:fillRect/>
           </a:stretch>
@@ -7752,13 +7689,6 @@
             <a:schemeClr val="lt1"/>
           </a:fontRef>
         </p:style>
-        <p:txBody>
-          <a:bodyPr rtlCol="0" anchor="ctr"/>
-          <a:lstStyle/>
-          <a:p>
-            <a:pPr algn="ctr"/>
-          </a:p>
-        </p:txBody>
       </p:sp>
       <p:pic>
         <p:nvPicPr>
@@ -7769,7 +7699,7 @@
           <p:nvPr/>
         </p:nvPicPr>
         <p:blipFill>
-          <a:blip r:embed="rId4"/>
+          <a:blip ns2:embed="rId4"/>
           <a:stretch>
             <a:fillRect/>
           </a:stretch>
@@ -7906,7 +7836,7 @@
 </file>
 
 <file path=ppt/slides/slide15.xml><?xml version="1.0" encoding="utf-8"?>
-<p:sld xmlns:a="http://schemas.openxmlformats.org/drawingml/2006/main" xmlns:p="http://schemas.openxmlformats.org/presentationml/2006/main" xmlns:r="http://schemas.openxmlformats.org/officeDocument/2006/relationships">
+<p:sld xmlns:a="http://schemas.openxmlformats.org/drawingml/2006/main" xmlns:ns2="http://schemas.openxmlformats.org/officeDocument/2006/relationships" xmlns:p="http://schemas.openxmlformats.org/presentationml/2006/main">
   <p:cSld>
     <p:spTree>
       <p:nvGrpSpPr>
@@ -7950,13 +7880,6 @@
             <a:schemeClr val="lt1"/>
           </a:fontRef>
         </p:style>
-        <p:txBody>
-          <a:bodyPr rtlCol="0" anchor="ctr"/>
-          <a:lstStyle/>
-          <a:p>
-            <a:pPr algn="ctr"/>
-          </a:p>
-        </p:txBody>
       </p:sp>
       <p:pic>
         <p:nvPicPr>
@@ -7967,7 +7890,7 @@
           <p:nvPr/>
         </p:nvPicPr>
         <p:blipFill>
-          <a:blip r:embed="rId2"/>
+          <a:blip ns2:embed="rId2"/>
           <a:stretch>
             <a:fillRect/>
           </a:stretch>
@@ -8136,7 +8059,7 @@
           <p:nvPr/>
         </p:nvPicPr>
         <p:blipFill>
-          <a:blip r:embed="rId3"/>
+          <a:blip ns2:embed="rId3"/>
           <a:stretch>
             <a:fillRect/>
           </a:stretch>
@@ -8160,7 +8083,7 @@
           <p:nvPr/>
         </p:nvPicPr>
         <p:blipFill>
-          <a:blip r:embed="rId4"/>
+          <a:blip ns2:embed="rId4"/>
           <a:stretch>
             <a:fillRect/>
           </a:stretch>
@@ -8210,13 +8133,6 @@
             <a:schemeClr val="lt1"/>
           </a:fontRef>
         </p:style>
-        <p:txBody>
-          <a:bodyPr rtlCol="0" anchor="ctr"/>
-          <a:lstStyle/>
-          <a:p>
-            <a:pPr algn="ctr"/>
-          </a:p>
-        </p:txBody>
       </p:sp>
       <p:sp>
         <p:nvSpPr>
@@ -8274,7 +8190,7 @@
 </file>
 
 <file path=ppt/slides/slide16.xml><?xml version="1.0" encoding="utf-8"?>
-<p:sld xmlns:a="http://schemas.openxmlformats.org/drawingml/2006/main" xmlns:p="http://schemas.openxmlformats.org/presentationml/2006/main" xmlns:r="http://schemas.openxmlformats.org/officeDocument/2006/relationships">
+<p:sld xmlns:a="http://schemas.openxmlformats.org/drawingml/2006/main" xmlns:ns2="http://schemas.openxmlformats.org/officeDocument/2006/relationships" xmlns:p="http://schemas.openxmlformats.org/presentationml/2006/main">
   <p:cSld>
     <p:spTree>
       <p:nvGrpSpPr>
@@ -8318,13 +8234,6 @@
             <a:schemeClr val="lt1"/>
           </a:fontRef>
         </p:style>
-        <p:txBody>
-          <a:bodyPr rtlCol="0" anchor="ctr"/>
-          <a:lstStyle/>
-          <a:p>
-            <a:pPr algn="ctr"/>
-          </a:p>
-        </p:txBody>
       </p:sp>
       <p:pic>
         <p:nvPicPr>
@@ -8335,7 +8244,7 @@
           <p:nvPr/>
         </p:nvPicPr>
         <p:blipFill>
-          <a:blip r:embed="rId2"/>
+          <a:blip ns2:embed="rId2"/>
           <a:stretch>
             <a:fillRect/>
           </a:stretch>
@@ -8504,7 +8413,7 @@
           <p:nvPr/>
         </p:nvPicPr>
         <p:blipFill>
-          <a:blip r:embed="rId3"/>
+          <a:blip ns2:embed="rId3"/>
           <a:stretch>
             <a:fillRect/>
           </a:stretch>
@@ -8528,7 +8437,7 @@
           <p:nvPr/>
         </p:nvPicPr>
         <p:blipFill>
-          <a:blip r:embed="rId4"/>
+          <a:blip ns2:embed="rId4"/>
           <a:stretch>
             <a:fillRect/>
           </a:stretch>
@@ -8552,7 +8461,7 @@
           <p:nvPr/>
         </p:nvPicPr>
         <p:blipFill>
-          <a:blip r:embed="rId5"/>
+          <a:blip ns2:embed="rId5"/>
           <a:stretch>
             <a:fillRect/>
           </a:stretch>
@@ -8602,13 +8511,6 @@
             <a:schemeClr val="lt1"/>
           </a:fontRef>
         </p:style>
-        <p:txBody>
-          <a:bodyPr rtlCol="0" anchor="ctr"/>
-          <a:lstStyle/>
-          <a:p>
-            <a:pPr algn="ctr"/>
-          </a:p>
-        </p:txBody>
       </p:sp>
       <p:sp>
         <p:nvSpPr>
@@ -8666,7 +8568,7 @@
 </file>
 
 <file path=ppt/slides/slide17.xml><?xml version="1.0" encoding="utf-8"?>
-<p:sld xmlns:a="http://schemas.openxmlformats.org/drawingml/2006/main" xmlns:p="http://schemas.openxmlformats.org/presentationml/2006/main" xmlns:r="http://schemas.openxmlformats.org/officeDocument/2006/relationships">
+<p:sld xmlns:a="http://schemas.openxmlformats.org/drawingml/2006/main" xmlns:ns2="http://schemas.openxmlformats.org/officeDocument/2006/relationships" xmlns:p="http://schemas.openxmlformats.org/presentationml/2006/main">
   <p:cSld>
     <p:spTree>
       <p:nvGrpSpPr>
@@ -8710,13 +8612,6 @@
             <a:schemeClr val="lt1"/>
           </a:fontRef>
         </p:style>
-        <p:txBody>
-          <a:bodyPr rtlCol="0" anchor="ctr"/>
-          <a:lstStyle/>
-          <a:p>
-            <a:pPr algn="ctr"/>
-          </a:p>
-        </p:txBody>
       </p:sp>
       <p:pic>
         <p:nvPicPr>
@@ -8727,7 +8622,7 @@
           <p:nvPr/>
         </p:nvPicPr>
         <p:blipFill>
-          <a:blip r:embed="rId2"/>
+          <a:blip ns2:embed="rId2"/>
           <a:stretch>
             <a:fillRect/>
           </a:stretch>
@@ -9083,13 +8978,6 @@
             <a:schemeClr val="lt1"/>
           </a:fontRef>
         </p:style>
-        <p:txBody>
-          <a:bodyPr rtlCol="0" anchor="ctr"/>
-          <a:lstStyle/>
-          <a:p>
-            <a:pPr algn="ctr"/>
-          </a:p>
-        </p:txBody>
       </p:sp>
       <p:sp>
         <p:nvSpPr>
@@ -9266,7 +9154,7 @@
 </file>
 
 <file path=ppt/slides/slide18.xml><?xml version="1.0" encoding="utf-8"?>
-<p:sld xmlns:a="http://schemas.openxmlformats.org/drawingml/2006/main" xmlns:p="http://schemas.openxmlformats.org/presentationml/2006/main" xmlns:r="http://schemas.openxmlformats.org/officeDocument/2006/relationships">
+<p:sld xmlns:a="http://schemas.openxmlformats.org/drawingml/2006/main" xmlns:ns2="http://schemas.openxmlformats.org/officeDocument/2006/relationships" xmlns:p="http://schemas.openxmlformats.org/presentationml/2006/main">
   <p:cSld>
     <p:spTree>
       <p:nvGrpSpPr>
@@ -9310,13 +9198,6 @@
             <a:schemeClr val="lt1"/>
           </a:fontRef>
         </p:style>
-        <p:txBody>
-          <a:bodyPr rtlCol="0" anchor="ctr"/>
-          <a:lstStyle/>
-          <a:p>
-            <a:pPr algn="ctr"/>
-          </a:p>
-        </p:txBody>
       </p:sp>
       <p:pic>
         <p:nvPicPr>
@@ -9327,7 +9208,7 @@
           <p:nvPr/>
         </p:nvPicPr>
         <p:blipFill>
-          <a:blip r:embed="rId2"/>
+          <a:blip ns2:embed="rId2"/>
           <a:stretch>
             <a:fillRect/>
           </a:stretch>
@@ -9796,7 +9677,7 @@
 </file>
 
 <file path=ppt/slides/slide19.xml><?xml version="1.0" encoding="utf-8"?>
-<p:sld xmlns:a="http://schemas.openxmlformats.org/drawingml/2006/main" xmlns:p="http://schemas.openxmlformats.org/presentationml/2006/main" xmlns:r="http://schemas.openxmlformats.org/officeDocument/2006/relationships">
+<p:sld xmlns:a="http://schemas.openxmlformats.org/drawingml/2006/main" xmlns:ns2="http://schemas.openxmlformats.org/officeDocument/2006/relationships" xmlns:p="http://schemas.openxmlformats.org/presentationml/2006/main">
   <p:cSld>
     <p:spTree>
       <p:nvGrpSpPr>
@@ -9840,13 +9721,6 @@
             <a:schemeClr val="lt1"/>
           </a:fontRef>
         </p:style>
-        <p:txBody>
-          <a:bodyPr rtlCol="0" anchor="ctr"/>
-          <a:lstStyle/>
-          <a:p>
-            <a:pPr algn="ctr"/>
-          </a:p>
-        </p:txBody>
       </p:sp>
       <p:pic>
         <p:nvPicPr>
@@ -9857,7 +9731,7 @@
           <p:nvPr/>
         </p:nvPicPr>
         <p:blipFill>
-          <a:blip r:embed="rId2"/>
+          <a:blip ns2:embed="rId2"/>
           <a:stretch>
             <a:fillRect/>
           </a:stretch>
@@ -10212,7 +10086,7 @@
 </file>
 
 <file path=ppt/slides/slide2.xml><?xml version="1.0" encoding="utf-8"?>
-<p:sld xmlns:a="http://schemas.openxmlformats.org/drawingml/2006/main" xmlns:p="http://schemas.openxmlformats.org/presentationml/2006/main" xmlns:r="http://schemas.openxmlformats.org/officeDocument/2006/relationships">
+<p:sld xmlns:a="http://schemas.openxmlformats.org/drawingml/2006/main" xmlns:ns2="http://schemas.openxmlformats.org/officeDocument/2006/relationships" xmlns:p="http://schemas.openxmlformats.org/presentationml/2006/main">
   <p:cSld>
     <p:spTree>
       <p:nvGrpSpPr>
@@ -10256,13 +10130,6 @@
             <a:schemeClr val="lt1"/>
           </a:fontRef>
         </p:style>
-        <p:txBody>
-          <a:bodyPr rtlCol="0" anchor="ctr"/>
-          <a:lstStyle/>
-          <a:p>
-            <a:pPr algn="ctr"/>
-          </a:p>
-        </p:txBody>
       </p:sp>
       <p:pic>
         <p:nvPicPr>
@@ -10273,7 +10140,7 @@
           <p:nvPr/>
         </p:nvPicPr>
         <p:blipFill>
-          <a:blip r:embed="rId2"/>
+          <a:blip ns2:embed="rId2"/>
           <a:stretch>
             <a:fillRect/>
           </a:stretch>
@@ -10658,13 +10525,6 @@
             <a:schemeClr val="lt1"/>
           </a:fontRef>
         </p:style>
-        <p:txBody>
-          <a:bodyPr rtlCol="0" anchor="ctr"/>
-          <a:lstStyle/>
-          <a:p>
-            <a:pPr algn="ctr"/>
-          </a:p>
-        </p:txBody>
       </p:sp>
       <p:sp>
         <p:nvSpPr>
@@ -11098,7 +10958,7 @@
 </file>
 
 <file path=ppt/slides/slide20.xml><?xml version="1.0" encoding="utf-8"?>
-<p:sld xmlns:a="http://schemas.openxmlformats.org/drawingml/2006/main" xmlns:p="http://schemas.openxmlformats.org/presentationml/2006/main" xmlns:r="http://schemas.openxmlformats.org/officeDocument/2006/relationships">
+<p:sld xmlns:a="http://schemas.openxmlformats.org/drawingml/2006/main" xmlns:ns2="http://schemas.openxmlformats.org/officeDocument/2006/relationships" xmlns:p="http://schemas.openxmlformats.org/presentationml/2006/main">
   <p:cSld>
     <p:spTree>
       <p:nvGrpSpPr>
@@ -11116,7 +10976,7 @@
           <p:nvPr/>
         </p:nvPicPr>
         <p:blipFill>
-          <a:blip r:embed="rId2"/>
+          <a:blip ns2:embed="rId2"/>
           <a:stretch>
             <a:fillRect/>
           </a:stretch>
@@ -11166,13 +11026,6 @@
             <a:schemeClr val="lt1"/>
           </a:fontRef>
         </p:style>
-        <p:txBody>
-          <a:bodyPr rtlCol="0" anchor="ctr"/>
-          <a:lstStyle/>
-          <a:p>
-            <a:pPr algn="ctr"/>
-          </a:p>
-        </p:txBody>
       </p:sp>
       <p:sp>
         <p:nvSpPr>
@@ -11277,7 +11130,7 @@
 </file>
 
 <file path=ppt/slides/slide3.xml><?xml version="1.0" encoding="utf-8"?>
-<p:sld xmlns:a="http://schemas.openxmlformats.org/drawingml/2006/main" xmlns:p="http://schemas.openxmlformats.org/presentationml/2006/main" xmlns:r="http://schemas.openxmlformats.org/officeDocument/2006/relationships">
+<p:sld xmlns:a="http://schemas.openxmlformats.org/drawingml/2006/main" xmlns:ns2="http://schemas.openxmlformats.org/officeDocument/2006/relationships" xmlns:p="http://schemas.openxmlformats.org/presentationml/2006/main">
   <p:cSld>
     <p:spTree>
       <p:nvGrpSpPr>
@@ -11321,13 +11174,6 @@
             <a:schemeClr val="lt1"/>
           </a:fontRef>
         </p:style>
-        <p:txBody>
-          <a:bodyPr rtlCol="0" anchor="ctr"/>
-          <a:lstStyle/>
-          <a:p>
-            <a:pPr algn="ctr"/>
-          </a:p>
-        </p:txBody>
       </p:sp>
       <p:pic>
         <p:nvPicPr>
@@ -11338,7 +11184,7 @@
           <p:nvPr/>
         </p:nvPicPr>
         <p:blipFill>
-          <a:blip r:embed="rId2"/>
+          <a:blip ns2:embed="rId2"/>
           <a:stretch>
             <a:fillRect/>
           </a:stretch>
@@ -11507,7 +11353,7 @@
           <p:nvPr/>
         </p:nvPicPr>
         <p:blipFill>
-          <a:blip r:embed="rId3"/>
+          <a:blip ns2:embed="rId3"/>
           <a:stretch>
             <a:fillRect/>
           </a:stretch>
@@ -11531,7 +11377,7 @@
           <p:nvPr/>
         </p:nvPicPr>
         <p:blipFill>
-          <a:blip r:embed="rId4"/>
+          <a:blip ns2:embed="rId4"/>
           <a:stretch>
             <a:fillRect/>
           </a:stretch>
@@ -11581,13 +11427,6 @@
             <a:schemeClr val="lt1"/>
           </a:fontRef>
         </p:style>
-        <p:txBody>
-          <a:bodyPr rtlCol="0" anchor="ctr"/>
-          <a:lstStyle/>
-          <a:p>
-            <a:pPr algn="ctr"/>
-          </a:p>
-        </p:txBody>
       </p:sp>
       <p:sp>
         <p:nvSpPr>
@@ -11715,7 +11554,7 @@
 </file>
 
 <file path=ppt/slides/slide4.xml><?xml version="1.0" encoding="utf-8"?>
-<p:sld xmlns:a="http://schemas.openxmlformats.org/drawingml/2006/main" xmlns:p="http://schemas.openxmlformats.org/presentationml/2006/main" xmlns:r="http://schemas.openxmlformats.org/officeDocument/2006/relationships">
+<p:sld xmlns:a="http://schemas.openxmlformats.org/drawingml/2006/main" xmlns:ns2="http://schemas.openxmlformats.org/officeDocument/2006/relationships" xmlns:p="http://schemas.openxmlformats.org/presentationml/2006/main">
   <p:cSld>
     <p:spTree>
       <p:nvGrpSpPr>
@@ -11759,13 +11598,6 @@
             <a:schemeClr val="lt1"/>
           </a:fontRef>
         </p:style>
-        <p:txBody>
-          <a:bodyPr rtlCol="0" anchor="ctr"/>
-          <a:lstStyle/>
-          <a:p>
-            <a:pPr algn="ctr"/>
-          </a:p>
-        </p:txBody>
       </p:sp>
       <p:pic>
         <p:nvPicPr>
@@ -11776,7 +11608,7 @@
           <p:nvPr/>
         </p:nvPicPr>
         <p:blipFill>
-          <a:blip r:embed="rId2"/>
+          <a:blip ns2:embed="rId2"/>
           <a:stretch>
             <a:fillRect/>
           </a:stretch>
@@ -12066,13 +11898,6 @@
             <a:schemeClr val="lt1"/>
           </a:fontRef>
         </p:style>
-        <p:txBody>
-          <a:bodyPr rtlCol="0" anchor="ctr"/>
-          <a:lstStyle/>
-          <a:p>
-            <a:pPr algn="ctr"/>
-          </a:p>
-        </p:txBody>
       </p:sp>
       <p:sp>
         <p:nvSpPr>
@@ -12249,7 +12074,7 @@
 </file>
 
 <file path=ppt/slides/slide5.xml><?xml version="1.0" encoding="utf-8"?>
-<p:sld xmlns:a="http://schemas.openxmlformats.org/drawingml/2006/main" xmlns:p="http://schemas.openxmlformats.org/presentationml/2006/main" xmlns:r="http://schemas.openxmlformats.org/officeDocument/2006/relationships">
+<p:sld xmlns:a="http://schemas.openxmlformats.org/drawingml/2006/main" xmlns:ns2="http://schemas.openxmlformats.org/officeDocument/2006/relationships" xmlns:p="http://schemas.openxmlformats.org/presentationml/2006/main">
   <p:cSld>
     <p:spTree>
       <p:nvGrpSpPr>
@@ -12293,13 +12118,6 @@
             <a:schemeClr val="lt1"/>
           </a:fontRef>
         </p:style>
-        <p:txBody>
-          <a:bodyPr rtlCol="0" anchor="ctr"/>
-          <a:lstStyle/>
-          <a:p>
-            <a:pPr algn="ctr"/>
-          </a:p>
-        </p:txBody>
       </p:sp>
       <p:pic>
         <p:nvPicPr>
@@ -12310,7 +12128,7 @@
           <p:nvPr/>
         </p:nvPicPr>
         <p:blipFill>
-          <a:blip r:embed="rId2"/>
+          <a:blip ns2:embed="rId2"/>
           <a:stretch>
             <a:fillRect/>
           </a:stretch>
@@ -12805,13 +12623,6 @@
             <a:schemeClr val="lt1"/>
           </a:fontRef>
         </p:style>
-        <p:txBody>
-          <a:bodyPr rtlCol="0" anchor="ctr"/>
-          <a:lstStyle/>
-          <a:p>
-            <a:pPr algn="ctr"/>
-          </a:p>
-        </p:txBody>
       </p:sp>
       <p:sp>
         <p:nvSpPr>
@@ -13245,7 +13056,7 @@
 </file>
 
 <file path=ppt/slides/slide6.xml><?xml version="1.0" encoding="utf-8"?>
-<p:sld xmlns:a="http://schemas.openxmlformats.org/drawingml/2006/main" xmlns:p="http://schemas.openxmlformats.org/presentationml/2006/main" xmlns:r="http://schemas.openxmlformats.org/officeDocument/2006/relationships">
+<p:sld xmlns:a="http://schemas.openxmlformats.org/drawingml/2006/main" xmlns:ns2="http://schemas.openxmlformats.org/officeDocument/2006/relationships" xmlns:p="http://schemas.openxmlformats.org/presentationml/2006/main">
   <p:cSld>
     <p:spTree>
       <p:nvGrpSpPr>
@@ -13289,13 +13100,6 @@
             <a:schemeClr val="lt1"/>
           </a:fontRef>
         </p:style>
-        <p:txBody>
-          <a:bodyPr rtlCol="0" anchor="ctr"/>
-          <a:lstStyle/>
-          <a:p>
-            <a:pPr algn="ctr"/>
-          </a:p>
-        </p:txBody>
       </p:sp>
       <p:pic>
         <p:nvPicPr>
@@ -13306,7 +13110,7 @@
           <p:nvPr/>
         </p:nvPicPr>
         <p:blipFill>
-          <a:blip r:embed="rId2"/>
+          <a:blip ns2:embed="rId2"/>
           <a:stretch>
             <a:fillRect/>
           </a:stretch>
@@ -13475,7 +13279,7 @@
           <p:nvPr/>
         </p:nvPicPr>
         <p:blipFill>
-          <a:blip r:embed="rId3"/>
+          <a:blip ns2:embed="rId3"/>
           <a:stretch>
             <a:fillRect/>
           </a:stretch>
@@ -13499,7 +13303,7 @@
           <p:nvPr/>
         </p:nvPicPr>
         <p:blipFill>
-          <a:blip r:embed="rId4"/>
+          <a:blip ns2:embed="rId4"/>
           <a:stretch>
             <a:fillRect/>
           </a:stretch>
@@ -13549,13 +13353,6 @@
             <a:schemeClr val="lt1"/>
           </a:fontRef>
         </p:style>
-        <p:txBody>
-          <a:bodyPr rtlCol="0" anchor="ctr"/>
-          <a:lstStyle/>
-          <a:p>
-            <a:pPr algn="ctr"/>
-          </a:p>
-        </p:txBody>
       </p:sp>
       <p:sp>
         <p:nvSpPr>
@@ -13681,7 +13478,7 @@
 </file>
 
 <file path=ppt/slides/slide7.xml><?xml version="1.0" encoding="utf-8"?>
-<p:sld xmlns:a="http://schemas.openxmlformats.org/drawingml/2006/main" xmlns:p="http://schemas.openxmlformats.org/presentationml/2006/main" xmlns:r="http://schemas.openxmlformats.org/officeDocument/2006/relationships">
+<p:sld xmlns:a="http://schemas.openxmlformats.org/drawingml/2006/main" xmlns:ns2="http://schemas.openxmlformats.org/officeDocument/2006/relationships" xmlns:p="http://schemas.openxmlformats.org/presentationml/2006/main">
   <p:cSld>
     <p:spTree>
       <p:nvGrpSpPr>
@@ -13725,13 +13522,6 @@
             <a:schemeClr val="lt1"/>
           </a:fontRef>
         </p:style>
-        <p:txBody>
-          <a:bodyPr rtlCol="0" anchor="ctr"/>
-          <a:lstStyle/>
-          <a:p>
-            <a:pPr algn="ctr"/>
-          </a:p>
-        </p:txBody>
       </p:sp>
       <p:pic>
         <p:nvPicPr>
@@ -13742,7 +13532,7 @@
           <p:nvPr/>
         </p:nvPicPr>
         <p:blipFill>
-          <a:blip r:embed="rId2"/>
+          <a:blip ns2:embed="rId2"/>
           <a:stretch>
             <a:fillRect/>
           </a:stretch>
@@ -14240,13 +14030,6 @@
             <a:schemeClr val="lt1"/>
           </a:fontRef>
         </p:style>
-        <p:txBody>
-          <a:bodyPr rtlCol="0" anchor="ctr"/>
-          <a:lstStyle/>
-          <a:p>
-            <a:pPr algn="ctr"/>
-          </a:p>
-        </p:txBody>
       </p:sp>
       <p:sp>
         <p:nvSpPr>
@@ -14374,7 +14157,7 @@
 </file>
 
 <file path=ppt/slides/slide8.xml><?xml version="1.0" encoding="utf-8"?>
-<p:sld xmlns:a="http://schemas.openxmlformats.org/drawingml/2006/main" xmlns:p="http://schemas.openxmlformats.org/presentationml/2006/main" xmlns:r="http://schemas.openxmlformats.org/officeDocument/2006/relationships">
+<p:sld xmlns:a="http://schemas.openxmlformats.org/drawingml/2006/main" xmlns:ns2="http://schemas.openxmlformats.org/officeDocument/2006/relationships" xmlns:p="http://schemas.openxmlformats.org/presentationml/2006/main">
   <p:cSld>
     <p:spTree>
       <p:nvGrpSpPr>
@@ -14418,13 +14201,6 @@
             <a:schemeClr val="lt1"/>
           </a:fontRef>
         </p:style>
-        <p:txBody>
-          <a:bodyPr rtlCol="0" anchor="ctr"/>
-          <a:lstStyle/>
-          <a:p>
-            <a:pPr algn="ctr"/>
-          </a:p>
-        </p:txBody>
       </p:sp>
       <p:pic>
         <p:nvPicPr>
@@ -14435,7 +14211,7 @@
           <p:nvPr/>
         </p:nvPicPr>
         <p:blipFill>
-          <a:blip r:embed="rId2"/>
+          <a:blip ns2:embed="rId2"/>
           <a:stretch>
             <a:fillRect/>
           </a:stretch>
@@ -14967,13 +14743,6 @@
             <a:schemeClr val="lt1"/>
           </a:fontRef>
         </p:style>
-        <p:txBody>
-          <a:bodyPr rtlCol="0" anchor="ctr"/>
-          <a:lstStyle/>
-          <a:p>
-            <a:pPr algn="ctr"/>
-          </a:p>
-        </p:txBody>
       </p:sp>
       <p:sp>
         <p:nvSpPr>
@@ -15103,7 +14872,7 @@
 </file>
 
 <file path=ppt/slides/slide9.xml><?xml version="1.0" encoding="utf-8"?>
-<p:sld xmlns:a="http://schemas.openxmlformats.org/drawingml/2006/main" xmlns:p="http://schemas.openxmlformats.org/presentationml/2006/main" xmlns:r="http://schemas.openxmlformats.org/officeDocument/2006/relationships">
+<p:sld xmlns:a="http://schemas.openxmlformats.org/drawingml/2006/main" xmlns:ns2="http://schemas.openxmlformats.org/officeDocument/2006/relationships" xmlns:p="http://schemas.openxmlformats.org/presentationml/2006/main">
   <p:cSld>
     <p:spTree>
       <p:nvGrpSpPr>
@@ -15147,13 +14916,6 @@
             <a:schemeClr val="lt1"/>
           </a:fontRef>
         </p:style>
-        <p:txBody>
-          <a:bodyPr rtlCol="0" anchor="ctr"/>
-          <a:lstStyle/>
-          <a:p>
-            <a:pPr algn="ctr"/>
-          </a:p>
-        </p:txBody>
       </p:sp>
       <p:pic>
         <p:nvPicPr>
@@ -15164,7 +14926,7 @@
           <p:nvPr/>
         </p:nvPicPr>
         <p:blipFill>
-          <a:blip r:embed="rId2"/>
+          <a:blip ns2:embed="rId2"/>
           <a:stretch>
             <a:fillRect/>
           </a:stretch>
@@ -15682,13 +15444,6 @@
             <a:schemeClr val="lt1"/>
           </a:fontRef>
         </p:style>
-        <p:txBody>
-          <a:bodyPr rtlCol="0" anchor="ctr"/>
-          <a:lstStyle/>
-          <a:p>
-            <a:pPr algn="ctr"/>
-          </a:p>
-        </p:txBody>
       </p:sp>
       <p:sp>
         <p:nvSpPr>

</xml_diff>